<commit_message>
Tutto consegnato, presentazione e tesi pronte. Fine.
</commit_message>
<xml_diff>
--- a/Presentazione_cerimonia_Guidi.pptx
+++ b/Presentazione_cerimonia_Guidi.pptx
@@ -197,7 +197,7 @@
           <a:p>
             <a:fld id="{E1383589-15D9-4CFE-9B4B-26AE81DF1623}" type="datetimeFigureOut">
               <a:rPr lang="it-IT" smtClean="0"/>
-              <a:t>04/04/2025</a:t>
+              <a:t>19/07/2026</a:t>
             </a:fld>
             <a:endParaRPr lang="it-IT"/>
           </a:p>
@@ -509,7 +509,7 @@
           <a:lstStyle/>
           <a:p>
             <a:r>
-              <a:t>Buonasera a tutti. In parole semplici: i programmi di intelligenza artificiale come ChatGPT di solito girano su enormi centri di calcolo che consumano tantissima energia. Io mi sono chiesto se si possano far funzionare su un piccolo computer da poche decine di euro, il Raspberry Pi, consumando molto meno. Ho messo alla prova sei di questi programmi, misurando quanta energia consumano, quanto sono bravi a rispondere e quanto sono veloci. La risposta e' si': anche un dispositivo minuscolo ce la fa, in modo efficiente. E' un piccolo passo verso un'intelligenza artificiale piu' sostenibile e piu' vicina a ognuno di noi. Grazie.</a:t>
+              <a:t>Buonasera a tutti. In parole semplici: i programmi di intelligenza artificiale come ChatGPT di solito girano su enormi centri di calcolo che consumano tantissima energia. Io mi sono chiesto se si possano far funzionare su un piccolo computer da meno di cento euro, il Raspberry Pi, consumando molto meno. Ho messo alla prova sei di questi programmi, misurando quanta energia consumano, quanto sono bravi a rispondere e quanto sono veloci. La risposta e' si': anche un dispositivo minuscolo ce la fa, in modo efficiente. E' un piccolo passo verso un'intelligenza artificiale piu' sostenibile e piu' vicina a ognuno di noi. Grazie.</a:t>
             </a:r>
           </a:p>
         </p:txBody>
@@ -790,7 +790,7 @@
             <a:fld id="{1D8BD707-D9CF-40AE-B4C6-C98DA3205C09}" type="datetimeFigureOut">
               <a:rPr lang="en-US" smtClean="0"/>
               <a:pPr/>
-              <a:t>4/4/2025</a:t>
+              <a:t>7/19/2026</a:t>
             </a:fld>
             <a:endParaRPr lang="en-US"/>
           </a:p>
@@ -960,7 +960,7 @@
             <a:fld id="{1D8BD707-D9CF-40AE-B4C6-C98DA3205C09}" type="datetimeFigureOut">
               <a:rPr lang="en-US" smtClean="0"/>
               <a:pPr/>
-              <a:t>4/4/2025</a:t>
+              <a:t>7/19/2026</a:t>
             </a:fld>
             <a:endParaRPr lang="en-US"/>
           </a:p>
@@ -1140,7 +1140,7 @@
             <a:fld id="{1D8BD707-D9CF-40AE-B4C6-C98DA3205C09}" type="datetimeFigureOut">
               <a:rPr lang="en-US" smtClean="0"/>
               <a:pPr/>
-              <a:t>4/4/2025</a:t>
+              <a:t>7/19/2026</a:t>
             </a:fld>
             <a:endParaRPr lang="en-US"/>
           </a:p>
@@ -1310,7 +1310,7 @@
             <a:fld id="{1D8BD707-D9CF-40AE-B4C6-C98DA3205C09}" type="datetimeFigureOut">
               <a:rPr lang="en-US" smtClean="0"/>
               <a:pPr/>
-              <a:t>4/4/2025</a:t>
+              <a:t>7/19/2026</a:t>
             </a:fld>
             <a:endParaRPr lang="en-US"/>
           </a:p>
@@ -1557,7 +1557,7 @@
             <a:fld id="{1D8BD707-D9CF-40AE-B4C6-C98DA3205C09}" type="datetimeFigureOut">
               <a:rPr lang="en-US" smtClean="0"/>
               <a:pPr/>
-              <a:t>4/4/2025</a:t>
+              <a:t>7/19/2026</a:t>
             </a:fld>
             <a:endParaRPr lang="en-US"/>
           </a:p>
@@ -1844,7 +1844,7 @@
             <a:fld id="{1D8BD707-D9CF-40AE-B4C6-C98DA3205C09}" type="datetimeFigureOut">
               <a:rPr lang="en-US" smtClean="0"/>
               <a:pPr/>
-              <a:t>4/4/2025</a:t>
+              <a:t>7/19/2026</a:t>
             </a:fld>
             <a:endParaRPr lang="en-US"/>
           </a:p>
@@ -2265,7 +2265,7 @@
             <a:fld id="{1D8BD707-D9CF-40AE-B4C6-C98DA3205C09}" type="datetimeFigureOut">
               <a:rPr lang="en-US" smtClean="0"/>
               <a:pPr/>
-              <a:t>4/4/2025</a:t>
+              <a:t>7/19/2026</a:t>
             </a:fld>
             <a:endParaRPr lang="en-US"/>
           </a:p>
@@ -2384,7 +2384,7 @@
             <a:fld id="{1D8BD707-D9CF-40AE-B4C6-C98DA3205C09}" type="datetimeFigureOut">
               <a:rPr lang="en-US" smtClean="0"/>
               <a:pPr/>
-              <a:t>4/4/2025</a:t>
+              <a:t>7/19/2026</a:t>
             </a:fld>
             <a:endParaRPr lang="en-US"/>
           </a:p>
@@ -2481,7 +2481,7 @@
             <a:fld id="{1D8BD707-D9CF-40AE-B4C6-C98DA3205C09}" type="datetimeFigureOut">
               <a:rPr lang="en-US" smtClean="0"/>
               <a:pPr/>
-              <a:t>4/4/2025</a:t>
+              <a:t>7/19/2026</a:t>
             </a:fld>
             <a:endParaRPr lang="en-US"/>
           </a:p>
@@ -2758,7 +2758,7 @@
             <a:fld id="{1D8BD707-D9CF-40AE-B4C6-C98DA3205C09}" type="datetimeFigureOut">
               <a:rPr lang="en-US" smtClean="0"/>
               <a:pPr/>
-              <a:t>4/4/2025</a:t>
+              <a:t>7/19/2026</a:t>
             </a:fld>
             <a:endParaRPr lang="en-US"/>
           </a:p>
@@ -3012,7 +3012,7 @@
             <a:fld id="{1D8BD707-D9CF-40AE-B4C6-C98DA3205C09}" type="datetimeFigureOut">
               <a:rPr lang="en-US" smtClean="0"/>
               <a:pPr/>
-              <a:t>4/4/2025</a:t>
+              <a:t>7/19/2026</a:t>
             </a:fld>
             <a:endParaRPr lang="en-US"/>
           </a:p>
@@ -3225,7 +3225,7 @@
             <a:fld id="{1D8BD707-D9CF-40AE-B4C6-C98DA3205C09}" type="datetimeFigureOut">
               <a:rPr lang="en-US" smtClean="0"/>
               <a:pPr/>
-              <a:t>4/4/2025</a:t>
+              <a:t>7/19/2026</a:t>
             </a:fld>
             <a:endParaRPr lang="en-US"/>
           </a:p>
@@ -4340,7 +4340,7 @@
         <p:spPr>
           <a:xfrm>
             <a:off x="220435" y="3221309"/>
-            <a:ext cx="5172464" cy="323165"/>
+            <a:ext cx="5172464" cy="3093154"/>
           </a:xfrm>
           <a:prstGeom prst="rect">
             <a:avLst/>
@@ -4355,7 +4355,181 @@
           <a:p>
             <a:r>
               <a:rPr lang="it-IT" sz="1500" dirty="0"/>
-              <a:t>I programmi di intelligenza artificiale, come quelli dietro ChatGPT, di solito funzionano su enormi centri di calcolo che consumano moltissima energia. In questa tesi ho verificato se possono girare direttamente su un piccolo computer da poche decine di euro, il Raspberry Pi, consumando poco. Ho confrontato sei di questi programmi misurando quanta energia usano, quanto sono bravi a rispondere e quanto sono veloci. Il risultato e' positivo: anche un dispositivo minuscolo riesce a eseguirli in modo efficiente, un passo verso un'intelligenza artificiale piu' sostenibile e vicina a noi.</a:t>
+              <a:t>I </a:t>
+            </a:r>
+            <a:r>
+              <a:rPr lang="it-IT" sz="1500" b="1" dirty="0"/>
+              <a:t>modelli di intelligenza artificiale</a:t>
+            </a:r>
+            <a:r>
+              <a:rPr lang="it-IT" sz="1500" dirty="0"/>
+              <a:t>, come ad esempio </a:t>
+            </a:r>
+            <a:r>
+              <a:rPr lang="it-IT" sz="1500" i="1" dirty="0"/>
+              <a:t>ChatGPT</a:t>
+            </a:r>
+            <a:r>
+              <a:rPr lang="it-IT" sz="1500" dirty="0"/>
+              <a:t>, di solito funzionano su </a:t>
+            </a:r>
+            <a:r>
+              <a:rPr lang="it-IT" sz="1500" b="1" dirty="0"/>
+              <a:t>enormi centri di calcolo</a:t>
+            </a:r>
+            <a:r>
+              <a:rPr lang="it-IT" sz="1500" dirty="0"/>
+              <a:t> che </a:t>
+            </a:r>
+            <a:r>
+              <a:rPr lang="it-IT" sz="1500" b="1" dirty="0"/>
+              <a:t>consumano moltissima energia</a:t>
+            </a:r>
+            <a:r>
+              <a:rPr lang="it-IT" sz="1500" dirty="0"/>
+              <a:t>. In questa tesi ho verificato se alcuni modelli esistenti possono girare direttamente su </a:t>
+            </a:r>
+            <a:r>
+              <a:rPr lang="it-IT" sz="1500" b="1" dirty="0"/>
+              <a:t>un piccolo computer </a:t>
+            </a:r>
+            <a:r>
+              <a:rPr lang="it-IT" sz="1500" dirty="0"/>
+              <a:t>da meno di cento euro, il </a:t>
+            </a:r>
+            <a:r>
+              <a:rPr lang="it-IT" sz="1500" i="1" dirty="0"/>
+              <a:t>Raspberry Pi 5</a:t>
+            </a:r>
+            <a:r>
+              <a:rPr lang="it-IT" sz="1500" dirty="0"/>
+              <a:t> (RAM 8 GB), </a:t>
+            </a:r>
+            <a:r>
+              <a:rPr lang="it-IT" sz="1500" b="1" dirty="0"/>
+              <a:t>consumando poco</a:t>
+            </a:r>
+            <a:r>
+              <a:rPr lang="it-IT" sz="1500" dirty="0"/>
+              <a:t>. Ho confrontato </a:t>
+            </a:r>
+            <a:r>
+              <a:rPr lang="it-IT" sz="1500" b="1" dirty="0"/>
+              <a:t>sei </a:t>
+            </a:r>
+            <a:r>
+              <a:rPr lang="it-IT" sz="1500" dirty="0"/>
+              <a:t>di questi</a:t>
+            </a:r>
+            <a:r>
+              <a:rPr lang="it-IT" sz="1500" b="1" dirty="0"/>
+              <a:t> </a:t>
+            </a:r>
+            <a:r>
+              <a:rPr lang="it-IT" sz="1500" dirty="0"/>
+              <a:t>modelli</a:t>
+            </a:r>
+            <a:r>
+              <a:rPr lang="it-IT" sz="1500" b="1" dirty="0"/>
+              <a:t> </a:t>
+            </a:r>
+            <a:r>
+              <a:rPr lang="it-IT" sz="1500" dirty="0"/>
+              <a:t>misurando </a:t>
+            </a:r>
+            <a:r>
+              <a:rPr lang="it-IT" sz="1500" b="1" dirty="0"/>
+              <a:t>quanta energia usano</a:t>
+            </a:r>
+            <a:r>
+              <a:rPr lang="it-IT" sz="1500" dirty="0"/>
+              <a:t>, </a:t>
+            </a:r>
+            <a:r>
+              <a:rPr lang="it-IT" sz="1500" b="1" dirty="0"/>
+              <a:t>quanto sono bravi a rispondere </a:t>
+            </a:r>
+            <a:r>
+              <a:rPr lang="it-IT" sz="1500" dirty="0"/>
+              <a:t>e </a:t>
+            </a:r>
+            <a:r>
+              <a:rPr lang="it-IT" sz="1500" b="1" dirty="0"/>
+              <a:t>quanto sono veloci</a:t>
+            </a:r>
+            <a:r>
+              <a:rPr lang="it-IT" sz="1500" dirty="0"/>
+              <a:t>. Per l’esecuzione di questi </a:t>
+            </a:r>
+            <a:r>
+              <a:rPr lang="it-IT" sz="1500"/>
+              <a:t>ho usato </a:t>
+            </a:r>
+            <a:r>
+              <a:rPr lang="it-IT" sz="1500" dirty="0"/>
+              <a:t>il framework </a:t>
+            </a:r>
+            <a:r>
+              <a:rPr lang="it-IT" sz="1500" i="1" dirty="0"/>
+              <a:t>llama.cpp</a:t>
+            </a:r>
+            <a:r>
+              <a:rPr lang="it-IT" sz="1500" dirty="0"/>
+              <a:t> e per le misurazioni di potenza il circuito integrato </a:t>
+            </a:r>
+            <a:r>
+              <a:rPr lang="it-IT" sz="1500" i="1" dirty="0"/>
+              <a:t>PMIC</a:t>
+            </a:r>
+            <a:r>
+              <a:rPr lang="it-IT" sz="1500" dirty="0"/>
+              <a:t> (</a:t>
+            </a:r>
+            <a:r>
+              <a:rPr lang="it-IT" sz="1500" i="1" dirty="0"/>
+              <a:t>Power Management </a:t>
+            </a:r>
+            <a:r>
+              <a:rPr lang="it-IT" sz="1500" i="1" dirty="0" err="1"/>
+              <a:t>Integrated</a:t>
+            </a:r>
+            <a:r>
+              <a:rPr lang="it-IT" sz="1500" i="1" dirty="0"/>
+              <a:t> Circuit</a:t>
+            </a:r>
+            <a:r>
+              <a:rPr lang="it-IT" sz="1500" dirty="0"/>
+              <a:t>).</a:t>
+            </a:r>
+          </a:p>
+          <a:p>
+            <a:r>
+              <a:rPr lang="it-IT" sz="1500" dirty="0"/>
+              <a:t>Il </a:t>
+            </a:r>
+            <a:r>
+              <a:rPr lang="it-IT" sz="1500" b="1" dirty="0"/>
+              <a:t>risultato è positivo</a:t>
+            </a:r>
+            <a:r>
+              <a:rPr lang="it-IT" sz="1500" dirty="0"/>
+              <a:t>: anche un dispositivo minuscolo riesce a eseguire modelli - anche grossi - in modo efficiente, un passo verso </a:t>
+            </a:r>
+            <a:r>
+              <a:rPr lang="it-IT" sz="1500" b="1" dirty="0"/>
+              <a:t>un'intelligenza artificiale più sostenibile </a:t>
+            </a:r>
+            <a:r>
+              <a:rPr lang="it-IT" sz="1500" dirty="0"/>
+              <a:t>e </a:t>
+            </a:r>
+            <a:r>
+              <a:rPr lang="it-IT" sz="1500" b="1" dirty="0"/>
+              <a:t>vicina a noi</a:t>
+            </a:r>
+            <a:r>
+              <a:rPr lang="it-IT" sz="1500" dirty="0"/>
+              <a:t>.</a:t>
             </a:r>
           </a:p>
         </p:txBody>
@@ -4405,21 +4579,7 @@
           <a:lstStyle/>
           <a:p>
             <a:pPr algn="ctr"/>
-            <a:r>
-              <a:rPr lang="it-IT" dirty="0">
-                <a:solidFill>
-                  <a:srgbClr val="9966FF"/>
-                </a:solidFill>
-                <a:effectLst>
-                  <a:outerShdw blurRad="38100" dist="38100" dir="2700000" algn="tl">
-                    <a:srgbClr val="000000">
-                      <a:alpha val="43137"/>
-                    </a:srgbClr>
-                  </a:outerShdw>
-                </a:effectLst>
-              </a:rPr>
-              <a:t/>
-            </a:r>
+            <a:endParaRPr/>
           </a:p>
         </p:txBody>
       </p:sp>
@@ -4438,7 +4598,7 @@
         <p:spPr>
           <a:xfrm>
             <a:off x="170094" y="1541403"/>
-            <a:ext cx="8693912" cy="1015663"/>
+            <a:ext cx="8693912" cy="1323439"/>
           </a:xfrm>
           <a:prstGeom prst="rect">
             <a:avLst/>
@@ -4466,7 +4626,15 @@
           <a:p>
             <a:r>
               <a:rPr lang="en-GB" sz="2000" b="1" dirty="0" err="1"/>
-              <a:t>Intelligenza artificiale a basso consumo su un piccolo computer</a:t>
+              <a:t>Valutazione</a:t>
+            </a:r>
+            <a:r>
+              <a:rPr lang="en-GB" sz="2000" b="1" dirty="0"/>
+              <a:t> del </a:t>
+            </a:r>
+            <a:r>
+              <a:rPr lang="en-GB" sz="2000" b="1" dirty="0" err="1"/>
+              <a:t>consumo</a:t>
             </a:r>
             <a:r>
               <a:rPr lang="en-GB" sz="2000" b="1" dirty="0"/>
@@ -4474,7 +4642,15 @@
             </a:r>
             <a:r>
               <a:rPr lang="en-GB" sz="2000" b="1" dirty="0" err="1"/>
-              <a:t/>
+              <a:t>energetico</a:t>
+            </a:r>
+            <a:r>
+              <a:rPr lang="en-GB" sz="2000" b="1" dirty="0"/>
+              <a:t> di Large Language Model in </a:t>
+            </a:r>
+            <a:r>
+              <a:rPr lang="en-GB" sz="2000" b="1" dirty="0" err="1"/>
+              <a:t>dispositivi</a:t>
             </a:r>
             <a:r>
               <a:rPr lang="en-GB" sz="2000" b="1" dirty="0"/>
@@ -4482,50 +4658,14 @@
             </a:r>
             <a:r>
               <a:rPr lang="en-GB" sz="2000" b="1" dirty="0" err="1"/>
-              <a:t/>
+              <a:t>dell’Internet</a:t>
             </a:r>
             <a:r>
               <a:rPr lang="en-GB" sz="2000" b="1" dirty="0"/>
-              <a:t/>
-            </a:r>
-            <a:r>
-              <a:rPr lang="en-GB" sz="2000" b="1" dirty="0" err="1"/>
-              <a:t/>
-            </a:r>
-            <a:r>
-              <a:rPr lang="en-GB" sz="2000" b="1" dirty="0"/>
-              <a:t> </a:t>
-            </a:r>
-            <a:r>
-              <a:rPr lang="en-GB" sz="2000" b="1" dirty="0" err="1"/>
-              <a:t/>
-            </a:r>
-            <a:r>
-              <a:rPr lang="en-GB" sz="2000" b="1" dirty="0"/>
-              <a:t> </a:t>
-            </a:r>
-            <a:r>
-              <a:rPr lang="en-GB" sz="2000" b="1" dirty="0" err="1"/>
-              <a:t/>
-            </a:r>
-            <a:r>
-              <a:rPr lang="en-GB" sz="2000" b="1" dirty="0"/>
-              <a:t> </a:t>
-            </a:r>
-          </a:p>
-          <a:p>
-            <a:r>
-              <a:rPr lang="en-GB" sz="2000" b="1" dirty="0" err="1"/>
-              <a:t/>
-            </a:r>
-            <a:r>
-              <a:rPr lang="en-GB" sz="2000" b="1" dirty="0"/>
-              <a:t/>
-            </a:r>
-            <a:r>
-              <a:rPr lang="en-GB" sz="2000" b="1" dirty="0" err="1"/>
-              <a:t/>
-            </a:r>
+              <a:t> delle Cose</a:t>
+            </a:r>
+          </a:p>
+          <a:p>
             <a:endParaRPr lang="en-GB" sz="2000" b="1" dirty="0"/>
           </a:p>
         </p:txBody>
@@ -4611,18 +4751,6 @@
               <a:rPr lang="en-GB" sz="2800" b="1" dirty="0" err="1"/>
               <a:t>Dott. Dario Guidi</a:t>
             </a:r>
-            <a:r>
-              <a:rPr lang="en-GB" sz="2800" b="1" dirty="0"/>
-              <a:t/>
-            </a:r>
-            <a:r>
-              <a:rPr lang="en-GB" sz="2800" b="1" dirty="0" err="1"/>
-              <a:t/>
-            </a:r>
-            <a:r>
-              <a:rPr lang="en-GB" sz="2800" b="1" dirty="0"/>
-              <a:t/>
-            </a:r>
           </a:p>
         </p:txBody>
       </p:sp>
@@ -4671,20 +4799,12 @@
               <a:rPr lang="en-GB" b="1" dirty="0"/>
               <a:t>: Prof. Alessio Vecchio</a:t>
             </a:r>
-            <a:r>
-              <a:rPr lang="en-GB" b="1" dirty="0" err="1"/>
-              <a:t/>
-            </a:r>
-            <a:r>
-              <a:rPr lang="en-GB" b="1" dirty="0"/>
-              <a:t/>
-            </a:r>
           </a:p>
         </p:txBody>
       </p:sp>
       <p:pic>
         <p:nvPicPr>
-          <p:cNvPr id="34" name="Picture 33" descr="efficiency_jpt.png"/>
+          <p:cNvPr id="34" name="Picture 33" descr="diagram_v6.png"/>
           <p:cNvPicPr>
             <a:picLocks noChangeAspect="1"/>
           </p:cNvPicPr>
@@ -4698,8 +4818,8 @@
         </p:blipFill>
         <p:spPr>
           <a:xfrm>
-            <a:off x="6222846" y="3814606"/>
-            <a:ext cx="3685803" cy="2010438"/>
+            <a:off x="6225671" y="3163641"/>
+            <a:ext cx="3680153" cy="3312368"/>
           </a:xfrm>
           <a:prstGeom prst="rect">
             <a:avLst/>
@@ -5299,15 +5419,6 @@
 </file>
 
 <file path=customXml/item2.xml><?xml version="1.0" encoding="utf-8"?>
-<?mso-contentType ?>
-<FormTemplates xmlns="http://schemas.microsoft.com/sharepoint/v3/contenttype/forms">
-  <Display>DocumentLibraryForm</Display>
-  <Edit>DocumentLibraryForm</Edit>
-  <New>DocumentLibraryForm</New>
-</FormTemplates>
-</file>
-
-<file path=customXml/item3.xml><?xml version="1.0" encoding="utf-8"?>
 <ct:contentTypeSchema xmlns:ct="http://schemas.microsoft.com/office/2006/metadata/contentType" xmlns:ma="http://schemas.microsoft.com/office/2006/metadata/properties/metaAttributes" ct:_="" ma:_="" ma:contentTypeName="Document" ma:contentTypeID="0x01010075DAC3ED0EBB8B4F9FE54EF51318C557" ma:contentTypeVersion="4" ma:contentTypeDescription="Create a new document." ma:contentTypeScope="" ma:versionID="7e005ef059e69192172a5c7396b466fc">
   <xsd:schema xmlns:xsd="http://www.w3.org/2001/XMLSchema" xmlns:xs="http://www.w3.org/2001/XMLSchema" xmlns:p="http://schemas.microsoft.com/office/2006/metadata/properties" xmlns:ns2="b8f38329-fe82-4838-8fdd-4280d7b6e94e" targetNamespace="http://schemas.microsoft.com/office/2006/metadata/properties" ma:root="true" ma:fieldsID="424c390e64b462513100b9a7e084c2fa" ns2:_="">
     <xsd:import namespace="b8f38329-fe82-4838-8fdd-4280d7b6e94e"/>
@@ -5451,6 +5562,15 @@
 </ct:contentTypeSchema>
 </file>
 
+<file path=customXml/item3.xml><?xml version="1.0" encoding="utf-8"?>
+<?mso-contentType ?>
+<FormTemplates xmlns="http://schemas.microsoft.com/sharepoint/v3/contenttype/forms">
+  <Display>DocumentLibraryForm</Display>
+  <Edit>DocumentLibraryForm</Edit>
+  <New>DocumentLibraryForm</New>
+</FormTemplates>
+</file>
+
 <file path=customXml/itemProps1.xml><?xml version="1.0" encoding="utf-8"?>
 <ds:datastoreItem xmlns:ds="http://schemas.openxmlformats.org/officeDocument/2006/customXml" ds:itemID="{A37CD499-5F4A-42A5-8068-7C4C58B63BD9}">
   <ds:schemaRefs>
@@ -5468,14 +5588,6 @@
 </file>
 
 <file path=customXml/itemProps2.xml><?xml version="1.0" encoding="utf-8"?>
-<ds:datastoreItem xmlns:ds="http://schemas.openxmlformats.org/officeDocument/2006/customXml" ds:itemID="{448BE7BF-29D8-4C20-8A32-3787C900441F}">
-  <ds:schemaRefs>
-    <ds:schemaRef ds:uri="http://schemas.microsoft.com/sharepoint/v3/contenttype/forms"/>
-  </ds:schemaRefs>
-</ds:datastoreItem>
-</file>
-
-<file path=customXml/itemProps3.xml><?xml version="1.0" encoding="utf-8"?>
 <ds:datastoreItem xmlns:ds="http://schemas.openxmlformats.org/officeDocument/2006/customXml" ds:itemID="{8D3E8510-347C-488F-90AC-6506B782AECC}">
   <ds:schemaRefs>
     <ds:schemaRef ds:uri="http://schemas.microsoft.com/office/2006/metadata/contentType"/>
@@ -5491,4 +5603,12 @@
     <ds:schemaRef ds:uri="http://schemas.microsoft.com/internal/obd"/>
   </ds:schemaRefs>
 </ds:datastoreItem>
+</file>
+
+<file path=customXml/itemProps3.xml><?xml version="1.0" encoding="utf-8"?>
+<ds:datastoreItem xmlns:ds="http://schemas.openxmlformats.org/officeDocument/2006/customXml" ds:itemID="{448BE7BF-29D8-4C20-8A32-3787C900441F}">
+  <ds:schemaRefs>
+    <ds:schemaRef ds:uri="http://schemas.microsoft.com/sharepoint/v3/contenttype/forms"/>
+  </ds:schemaRefs>
+</ds:datastoreItem>
 </file>
</xml_diff>